<commit_message>
Live results, report/slides updated, teardown verified
</commit_message>
<xml_diff>
--- a/ppt/CostScale.pptx
+++ b/ppt/CostScale.pptx
@@ -585,7 +585,7 @@
           <a:lstStyle/>
           <a:p>
             <a:r>
-              <a:t>Under-prediction is cheap by design: the excess goes to Lambda, nothing is dropped. Over-prediction wastes f per idle unit-minute until the next decision. A reactive controller is wrong in the damaging way. In simulation we multiplied one hour per function by 3, 4 or 5 after the forecast was made: the hybrids served everything; a x5 spike adds $4.4k to $5.7k per month. The ML forecaster over-reacts after a spike because its features include the spiked hour; a production system would clip forecasts after an anomaly. Live arm D repeated this on AWS.</a:t>
+              <a:t>Under-prediction is cheap by design: the excess goes to Lambda, nothing is dropped. Over-prediction wastes f per idle unit-minute until the next decision. A reactive controller is wrong in the damaging way. In simulation we multiplied one hour per function by 3, 4 or 5 after the forecast was made: the hybrids served everything; a x5 spike adds $4.4k to $5.7k per month. The ML forecaster over-reacts after a spike because its features include the spiked hour; a production system would clip forecasts after an anomaly. Live arm D repeated this on AWS: no request failed, but about 20 percent were slower than the 800 millisecond target, because the load balancer let EC2 run at its full capacity and weight changes take about 12 seconds to apply. The fix we would try first is a safety factor on capacity; we did not test it.</a:t>
             </a:r>
           </a:p>
         </p:txBody>
@@ -1425,7 +1425,7 @@
           <a:lstStyle/>
           <a:p>
             <a:r>
-              <a:t>Live results pending.</a:t>
+              <a:t>Four arms on the same trace window, scaled to 28 requests per second and time-compressed, run from a laptop in Mumbai against the load balancer in ap-south-1. Arm A is ASG target tracking with everything on EC2; B and C use the controller with the static and ML forecasts; D is C with a 4x spike in the fourth hour. The table shows errors, share served by Lambda, p95 latency and cost computed from instance time and CloudWatch Lambda metrics. Be straightforward about what it shows. On this smooth ramp, reactive scaling (A) and the ML hybrid (C) cost the same, so we did not reproduce the simulated advantage over reactive scaling; the clear live win is against a static base, which cost more than twice as much because it idles. The spike arm D had no failed requests but about 20 percent of requests were slow, because the weights fed EC2 its full capacity and the weights take about 12 seconds to apply. Each arm ran once, so this supports the design and is not a statistical ranking. The replay agrees with arms A to C within about 2 percent in cost; for D it differs a lot because the closed-loop load generator slowed down under overload.</a:t>
             </a:r>
           </a:p>
         </p:txBody>
@@ -4514,17 +4514,6 @@
               <a:t/>
             </a:r>
           </a:p>
-          <a:p>
-            <a:r>
-              <a:rPr sz="1500">
-                <a:solidFill>
-                  <a:srgbClr val="52514E"/>
-                </a:solidFill>
-                <a:latin typeface="Calibri"/>
-              </a:rPr>
-              <a:t>ML-driven hybrid container and serverless resource management on AWS</a:t>
-            </a:r>
-          </a:p>
         </p:txBody>
       </p:sp>
       <p:sp>
@@ -4629,7 +4618,7 @@
                 </a:solidFill>
                 <a:latin typeface="Calibri"/>
               </a:rPr>
-              <a:t>• [TO FILL: student names and IDs]</a:t>
+              <a:t>• Anamay Narkar (16010123040)</a:t>
             </a:r>
           </a:p>
           <a:p>
@@ -4645,7 +4634,7 @@
                 </a:solidFill>
                 <a:latin typeface="Calibri"/>
               </a:rPr>
-              <a:t>• [TO FILL: programme, institute, course]</a:t>
+              <a:t>• Ananya Dhiman (16010123041)</a:t>
             </a:r>
           </a:p>
           <a:p>
@@ -4661,7 +4650,39 @@
                 </a:solidFill>
                 <a:latin typeface="Calibri"/>
               </a:rPr>
-              <a:t>• October 2026</a:t>
+              <a:t>• Anoushka Nelson (16010123049)</a:t>
+            </a:r>
+          </a:p>
+          <a:p>
+            <a:pPr>
+              <a:spcAft>
+                <a:spcPts val="800"/>
+              </a:spcAft>
+            </a:pPr>
+            <a:r>
+              <a:rPr sz="2000">
+                <a:solidFill>
+                  <a:srgbClr val="0B0B0B"/>
+                </a:solidFill>
+                <a:latin typeface="Calibri"/>
+              </a:rPr>
+              <a:t>• B.Tech Computer Engineering, K.J. Somaiya School of Engineering, Mumbai</a:t>
+            </a:r>
+          </a:p>
+          <a:p>
+            <a:pPr>
+              <a:spcAft>
+                <a:spcPts val="800"/>
+              </a:spcAft>
+            </a:pPr>
+            <a:r>
+              <a:rPr sz="2000">
+                <a:solidFill>
+                  <a:srgbClr val="0B0B0B"/>
+                </a:solidFill>
+                <a:latin typeface="Calibri"/>
+              </a:rPr>
+              <a:t>• [TO FILL: course name]  |  October 2026</a:t>
             </a:r>
           </a:p>
         </p:txBody>
@@ -4775,7 +4796,7 @@
                 </a:solidFill>
                 <a:latin typeface="Calibri"/>
               </a:rPr>
-              <a:t>Under-prediction goes to Lambda; nothing is dropped</a:t>
+              <a:t>Under-prediction goes to Lambda: nothing fails, but latency can suffer</a:t>
             </a:r>
           </a:p>
         </p:txBody>
@@ -4886,7 +4907,23 @@
                 </a:solidFill>
                 <a:latin typeface="Calibri"/>
               </a:rPr>
-              <a:t>• x5 spike: +$4.4k (rolling) / +$5.7k (ML) per month, 0% dropped</a:t>
+              <a:t>• Live arm D: 0 failed, but 20% of requests slower than 800 ms</a:t>
+            </a:r>
+          </a:p>
+          <a:p>
+            <a:pPr>
+              <a:spcAft>
+                <a:spcPts val="800"/>
+              </a:spcAft>
+            </a:pPr>
+            <a:r>
+              <a:rPr sz="1500">
+                <a:solidFill>
+                  <a:srgbClr val="0B0B0B"/>
+                </a:solidFill>
+                <a:latin typeface="Calibri"/>
+              </a:rPr>
+              <a:t>• x5 spike (sim): +$4.4k (rolling) / +$5.7k (ML) per month, 0% dropped</a:t>
             </a:r>
           </a:p>
         </p:txBody>
@@ -5423,7 +5460,7 @@
                 </a:solidFill>
                 <a:latin typeface="Calibri"/>
               </a:rPr>
-              <a:t>• Live AWS demo reconciled with simulator replay</a:t>
+              <a:t>• Live AWS runs: mechanism works; A ≈ C in cost on a smooth ramp; spike hurt latency</a:t>
             </a:r>
           </a:p>
         </p:txBody>
@@ -8321,7 +8358,707 @@
                 </a:solidFill>
                 <a:latin typeface="Calibri"/>
               </a:rPr>
-              <a:t>pending</a:t>
+              <a:t>Four arms, same trace, run once each</a:t>
+            </a:r>
+          </a:p>
+        </p:txBody>
+      </p:sp>
+      <p:pic>
+        <p:nvPicPr>
+          <p:cNvPr id="4" name="Picture 3" descr="live_timelines.png"/>
+          <p:cNvPicPr>
+            <a:picLocks noChangeAspect="1"/>
+          </p:cNvPicPr>
+          <p:nvPr/>
+        </p:nvPicPr>
+        <p:blipFill>
+          <a:blip r:embed="rId3"/>
+          <a:stretch>
+            <a:fillRect/>
+          </a:stretch>
+        </p:blipFill>
+        <p:spPr>
+          <a:xfrm>
+            <a:off x="365760" y="1371600"/>
+            <a:ext cx="6949440" cy="4420067"/>
+          </a:xfrm>
+          <a:prstGeom prst="rect">
+            <a:avLst/>
+          </a:prstGeom>
+        </p:spPr>
+      </p:pic>
+      <p:graphicFrame>
+        <p:nvGraphicFramePr>
+          <p:cNvPr id="5" name="Table 4"/>
+          <p:cNvGraphicFramePr>
+            <a:graphicFrameLocks noGrp="1"/>
+          </p:cNvGraphicFramePr>
+          <p:nvPr/>
+        </p:nvGraphicFramePr>
+        <p:xfrm>
+          <a:off x="7498079" y="1737360"/>
+          <a:ext cx="4480560" cy="2057400"/>
+        </p:xfrm>
+        <a:graphic>
+          <a:graphicData uri="http://schemas.openxmlformats.org/drawingml/2006/table">
+            <a:tbl>
+              <a:tblPr firstRow="1" bandRow="1">
+                <a:tableStyleId>{5C22544A-7EE6-4342-B048-85BDC9FD1C3A}</a:tableStyleId>
+              </a:tblPr>
+              <a:tblGrid>
+                <a:gridCol w="1280160"/>
+                <a:gridCol w="731520"/>
+                <a:gridCol w="868680"/>
+                <a:gridCol w="731520"/>
+                <a:gridCol w="868680"/>
+              </a:tblGrid>
+              <a:tr h="411480">
+                <a:tc>
+                  <a:txBody>
+                    <a:bodyPr/>
+                    <a:lstStyle/>
+                    <a:p>
+                      <a:r>
+                        <a:rPr sz="1100" b="1">
+                          <a:solidFill>
+                            <a:srgbClr val="0B0B0B"/>
+                          </a:solidFill>
+                          <a:latin typeface="Calibri"/>
+                        </a:rPr>
+                        <a:t>Arm</a:t>
+                      </a:r>
+                    </a:p>
+                  </a:txBody>
+                  <a:tcPr marT="30000" marB="30000">
+                    <a:solidFill>
+                      <a:srgbClr val="D9D9D9"/>
+                    </a:solidFill>
+                  </a:tcPr>
+                </a:tc>
+                <a:tc>
+                  <a:txBody>
+                    <a:bodyPr/>
+                    <a:lstStyle/>
+                    <a:p>
+                      <a:r>
+                        <a:rPr sz="1100" b="1">
+                          <a:solidFill>
+                            <a:srgbClr val="0B0B0B"/>
+                          </a:solidFill>
+                          <a:latin typeface="Calibri"/>
+                        </a:rPr>
+                        <a:t>Errors</a:t>
+                      </a:r>
+                    </a:p>
+                  </a:txBody>
+                  <a:tcPr marT="30000" marB="30000">
+                    <a:solidFill>
+                      <a:srgbClr val="D9D9D9"/>
+                    </a:solidFill>
+                  </a:tcPr>
+                </a:tc>
+                <a:tc>
+                  <a:txBody>
+                    <a:bodyPr/>
+                    <a:lstStyle/>
+                    <a:p>
+                      <a:r>
+                        <a:rPr sz="1100" b="1">
+                          <a:solidFill>
+                            <a:srgbClr val="0B0B0B"/>
+                          </a:solidFill>
+                          <a:latin typeface="Calibri"/>
+                        </a:rPr>
+                        <a:t>Lambda</a:t>
+                      </a:r>
+                    </a:p>
+                  </a:txBody>
+                  <a:tcPr marT="30000" marB="30000">
+                    <a:solidFill>
+                      <a:srgbClr val="D9D9D9"/>
+                    </a:solidFill>
+                  </a:tcPr>
+                </a:tc>
+                <a:tc>
+                  <a:txBody>
+                    <a:bodyPr/>
+                    <a:lstStyle/>
+                    <a:p>
+                      <a:r>
+                        <a:rPr sz="1100" b="1">
+                          <a:solidFill>
+                            <a:srgbClr val="0B0B0B"/>
+                          </a:solidFill>
+                          <a:latin typeface="Calibri"/>
+                        </a:rPr>
+                        <a:t>p95 ms</a:t>
+                      </a:r>
+                    </a:p>
+                  </a:txBody>
+                  <a:tcPr marT="30000" marB="30000">
+                    <a:solidFill>
+                      <a:srgbClr val="D9D9D9"/>
+                    </a:solidFill>
+                  </a:tcPr>
+                </a:tc>
+                <a:tc>
+                  <a:txBody>
+                    <a:bodyPr/>
+                    <a:lstStyle/>
+                    <a:p>
+                      <a:r>
+                        <a:rPr sz="1100" b="1">
+                          <a:solidFill>
+                            <a:srgbClr val="0B0B0B"/>
+                          </a:solidFill>
+                          <a:latin typeface="Calibri"/>
+                        </a:rPr>
+                        <a:t>Cost</a:t>
+                      </a:r>
+                    </a:p>
+                  </a:txBody>
+                  <a:tcPr marT="30000" marB="30000">
+                    <a:solidFill>
+                      <a:srgbClr val="D9D9D9"/>
+                    </a:solidFill>
+                  </a:tcPr>
+                </a:tc>
+              </a:tr>
+              <a:tr h="411480">
+                <a:tc>
+                  <a:txBody>
+                    <a:bodyPr/>
+                    <a:lstStyle/>
+                    <a:p>
+                      <a:r>
+                        <a:rPr sz="1100" b="0">
+                          <a:solidFill>
+                            <a:srgbClr val="0B0B0B"/>
+                          </a:solidFill>
+                          <a:latin typeface="Calibri"/>
+                        </a:rPr>
+                        <a:t>A reactive</a:t>
+                      </a:r>
+                    </a:p>
+                  </a:txBody>
+                  <a:tcPr marT="30000" marB="30000">
+                    <a:solidFill>
+                      <a:srgbClr val="FFFFFF"/>
+                    </a:solidFill>
+                  </a:tcPr>
+                </a:tc>
+                <a:tc>
+                  <a:txBody>
+                    <a:bodyPr/>
+                    <a:lstStyle/>
+                    <a:p>
+                      <a:r>
+                        <a:rPr sz="1100" b="0">
+                          <a:solidFill>
+                            <a:srgbClr val="0B0B0B"/>
+                          </a:solidFill>
+                          <a:latin typeface="Calibri"/>
+                        </a:rPr>
+                        <a:t>0.1%</a:t>
+                      </a:r>
+                    </a:p>
+                  </a:txBody>
+                  <a:tcPr marT="30000" marB="30000">
+                    <a:solidFill>
+                      <a:srgbClr val="FFFFFF"/>
+                    </a:solidFill>
+                  </a:tcPr>
+                </a:tc>
+                <a:tc>
+                  <a:txBody>
+                    <a:bodyPr/>
+                    <a:lstStyle/>
+                    <a:p>
+                      <a:r>
+                        <a:rPr sz="1100" b="0">
+                          <a:solidFill>
+                            <a:srgbClr val="0B0B0B"/>
+                          </a:solidFill>
+                          <a:latin typeface="Calibri"/>
+                        </a:rPr>
+                        <a:t>0%</a:t>
+                      </a:r>
+                    </a:p>
+                  </a:txBody>
+                  <a:tcPr marT="30000" marB="30000">
+                    <a:solidFill>
+                      <a:srgbClr val="FFFFFF"/>
+                    </a:solidFill>
+                  </a:tcPr>
+                </a:tc>
+                <a:tc>
+                  <a:txBody>
+                    <a:bodyPr/>
+                    <a:lstStyle/>
+                    <a:p>
+                      <a:r>
+                        <a:rPr sz="1100" b="0">
+                          <a:solidFill>
+                            <a:srgbClr val="0B0B0B"/>
+                          </a:solidFill>
+                          <a:latin typeface="Calibri"/>
+                        </a:rPr>
+                        <a:t>566</a:t>
+                      </a:r>
+                    </a:p>
+                  </a:txBody>
+                  <a:tcPr marT="30000" marB="30000">
+                    <a:solidFill>
+                      <a:srgbClr val="FFFFFF"/>
+                    </a:solidFill>
+                  </a:tcPr>
+                </a:tc>
+                <a:tc>
+                  <a:txBody>
+                    <a:bodyPr/>
+                    <a:lstStyle/>
+                    <a:p>
+                      <a:r>
+                        <a:rPr sz="1100" b="0">
+                          <a:solidFill>
+                            <a:srgbClr val="0B0B0B"/>
+                          </a:solidFill>
+                          <a:latin typeface="Calibri"/>
+                        </a:rPr>
+                        <a:t>$0.038</a:t>
+                      </a:r>
+                    </a:p>
+                  </a:txBody>
+                  <a:tcPr marT="30000" marB="30000">
+                    <a:solidFill>
+                      <a:srgbClr val="FFFFFF"/>
+                    </a:solidFill>
+                  </a:tcPr>
+                </a:tc>
+              </a:tr>
+              <a:tr h="411480">
+                <a:tc>
+                  <a:txBody>
+                    <a:bodyPr/>
+                    <a:lstStyle/>
+                    <a:p>
+                      <a:r>
+                        <a:rPr sz="1100" b="0">
+                          <a:solidFill>
+                            <a:srgbClr val="0B0B0B"/>
+                          </a:solidFill>
+                          <a:latin typeface="Calibri"/>
+                        </a:rPr>
+                        <a:t>B static</a:t>
+                      </a:r>
+                    </a:p>
+                  </a:txBody>
+                  <a:tcPr marT="30000" marB="30000">
+                    <a:solidFill>
+                      <a:srgbClr val="FFFFFF"/>
+                    </a:solidFill>
+                  </a:tcPr>
+                </a:tc>
+                <a:tc>
+                  <a:txBody>
+                    <a:bodyPr/>
+                    <a:lstStyle/>
+                    <a:p>
+                      <a:r>
+                        <a:rPr sz="1100" b="0">
+                          <a:solidFill>
+                            <a:srgbClr val="0B0B0B"/>
+                          </a:solidFill>
+                          <a:latin typeface="Calibri"/>
+                        </a:rPr>
+                        <a:t>0.0%</a:t>
+                      </a:r>
+                    </a:p>
+                  </a:txBody>
+                  <a:tcPr marT="30000" marB="30000">
+                    <a:solidFill>
+                      <a:srgbClr val="FFFFFF"/>
+                    </a:solidFill>
+                  </a:tcPr>
+                </a:tc>
+                <a:tc>
+                  <a:txBody>
+                    <a:bodyPr/>
+                    <a:lstStyle/>
+                    <a:p>
+                      <a:r>
+                        <a:rPr sz="1100" b="0">
+                          <a:solidFill>
+                            <a:srgbClr val="0B0B0B"/>
+                          </a:solidFill>
+                          <a:latin typeface="Calibri"/>
+                        </a:rPr>
+                        <a:t>1%</a:t>
+                      </a:r>
+                    </a:p>
+                  </a:txBody>
+                  <a:tcPr marT="30000" marB="30000">
+                    <a:solidFill>
+                      <a:srgbClr val="FFFFFF"/>
+                    </a:solidFill>
+                  </a:tcPr>
+                </a:tc>
+                <a:tc>
+                  <a:txBody>
+                    <a:bodyPr/>
+                    <a:lstStyle/>
+                    <a:p>
+                      <a:r>
+                        <a:rPr sz="1100" b="0">
+                          <a:solidFill>
+                            <a:srgbClr val="0B0B0B"/>
+                          </a:solidFill>
+                          <a:latin typeface="Calibri"/>
+                        </a:rPr>
+                        <a:t>517</a:t>
+                      </a:r>
+                    </a:p>
+                  </a:txBody>
+                  <a:tcPr marT="30000" marB="30000">
+                    <a:solidFill>
+                      <a:srgbClr val="FFFFFF"/>
+                    </a:solidFill>
+                  </a:tcPr>
+                </a:tc>
+                <a:tc>
+                  <a:txBody>
+                    <a:bodyPr/>
+                    <a:lstStyle/>
+                    <a:p>
+                      <a:r>
+                        <a:rPr sz="1100" b="0">
+                          <a:solidFill>
+                            <a:srgbClr val="0B0B0B"/>
+                          </a:solidFill>
+                          <a:latin typeface="Calibri"/>
+                        </a:rPr>
+                        <a:t>$0.085</a:t>
+                      </a:r>
+                    </a:p>
+                  </a:txBody>
+                  <a:tcPr marT="30000" marB="30000">
+                    <a:solidFill>
+                      <a:srgbClr val="FFFFFF"/>
+                    </a:solidFill>
+                  </a:tcPr>
+                </a:tc>
+              </a:tr>
+              <a:tr h="411480">
+                <a:tc>
+                  <a:txBody>
+                    <a:bodyPr/>
+                    <a:lstStyle/>
+                    <a:p>
+                      <a:r>
+                        <a:rPr sz="1100" b="0">
+                          <a:solidFill>
+                            <a:srgbClr val="0B0B0B"/>
+                          </a:solidFill>
+                          <a:latin typeface="Calibri"/>
+                        </a:rPr>
+                        <a:t>C ML</a:t>
+                      </a:r>
+                    </a:p>
+                  </a:txBody>
+                  <a:tcPr marT="30000" marB="30000">
+                    <a:solidFill>
+                      <a:srgbClr val="FFFFFF"/>
+                    </a:solidFill>
+                  </a:tcPr>
+                </a:tc>
+                <a:tc>
+                  <a:txBody>
+                    <a:bodyPr/>
+                    <a:lstStyle/>
+                    <a:p>
+                      <a:r>
+                        <a:rPr sz="1100" b="0">
+                          <a:solidFill>
+                            <a:srgbClr val="0B0B0B"/>
+                          </a:solidFill>
+                          <a:latin typeface="Calibri"/>
+                        </a:rPr>
+                        <a:t>0.0%</a:t>
+                      </a:r>
+                    </a:p>
+                  </a:txBody>
+                  <a:tcPr marT="30000" marB="30000">
+                    <a:solidFill>
+                      <a:srgbClr val="FFFFFF"/>
+                    </a:solidFill>
+                  </a:tcPr>
+                </a:tc>
+                <a:tc>
+                  <a:txBody>
+                    <a:bodyPr/>
+                    <a:lstStyle/>
+                    <a:p>
+                      <a:r>
+                        <a:rPr sz="1100" b="0">
+                          <a:solidFill>
+                            <a:srgbClr val="0B0B0B"/>
+                          </a:solidFill>
+                          <a:latin typeface="Calibri"/>
+                        </a:rPr>
+                        <a:t>1%</a:t>
+                      </a:r>
+                    </a:p>
+                  </a:txBody>
+                  <a:tcPr marT="30000" marB="30000">
+                    <a:solidFill>
+                      <a:srgbClr val="FFFFFF"/>
+                    </a:solidFill>
+                  </a:tcPr>
+                </a:tc>
+                <a:tc>
+                  <a:txBody>
+                    <a:bodyPr/>
+                    <a:lstStyle/>
+                    <a:p>
+                      <a:r>
+                        <a:rPr sz="1100" b="0">
+                          <a:solidFill>
+                            <a:srgbClr val="0B0B0B"/>
+                          </a:solidFill>
+                          <a:latin typeface="Calibri"/>
+                        </a:rPr>
+                        <a:t>585</a:t>
+                      </a:r>
+                    </a:p>
+                  </a:txBody>
+                  <a:tcPr marT="30000" marB="30000">
+                    <a:solidFill>
+                      <a:srgbClr val="FFFFFF"/>
+                    </a:solidFill>
+                  </a:tcPr>
+                </a:tc>
+                <a:tc>
+                  <a:txBody>
+                    <a:bodyPr/>
+                    <a:lstStyle/>
+                    <a:p>
+                      <a:r>
+                        <a:rPr sz="1100" b="0">
+                          <a:solidFill>
+                            <a:srgbClr val="0B0B0B"/>
+                          </a:solidFill>
+                          <a:latin typeface="Calibri"/>
+                        </a:rPr>
+                        <a:t>$0.039</a:t>
+                      </a:r>
+                    </a:p>
+                  </a:txBody>
+                  <a:tcPr marT="30000" marB="30000">
+                    <a:solidFill>
+                      <a:srgbClr val="FFFFFF"/>
+                    </a:solidFill>
+                  </a:tcPr>
+                </a:tc>
+              </a:tr>
+              <a:tr h="411480">
+                <a:tc>
+                  <a:txBody>
+                    <a:bodyPr/>
+                    <a:lstStyle/>
+                    <a:p>
+                      <a:r>
+                        <a:rPr sz="1100" b="0">
+                          <a:solidFill>
+                            <a:srgbClr val="0B0B0B"/>
+                          </a:solidFill>
+                          <a:latin typeface="Calibri"/>
+                        </a:rPr>
+                        <a:t>D ML + spike</a:t>
+                      </a:r>
+                    </a:p>
+                  </a:txBody>
+                  <a:tcPr marT="30000" marB="30000">
+                    <a:solidFill>
+                      <a:srgbClr val="FFFFFF"/>
+                    </a:solidFill>
+                  </a:tcPr>
+                </a:tc>
+                <a:tc>
+                  <a:txBody>
+                    <a:bodyPr/>
+                    <a:lstStyle/>
+                    <a:p>
+                      <a:r>
+                        <a:rPr sz="1100" b="0">
+                          <a:solidFill>
+                            <a:srgbClr val="0B0B0B"/>
+                          </a:solidFill>
+                          <a:latin typeface="Calibri"/>
+                        </a:rPr>
+                        <a:t>0.0%</a:t>
+                      </a:r>
+                    </a:p>
+                  </a:txBody>
+                  <a:tcPr marT="30000" marB="30000">
+                    <a:solidFill>
+                      <a:srgbClr val="FFFFFF"/>
+                    </a:solidFill>
+                  </a:tcPr>
+                </a:tc>
+                <a:tc>
+                  <a:txBody>
+                    <a:bodyPr/>
+                    <a:lstStyle/>
+                    <a:p>
+                      <a:r>
+                        <a:rPr sz="1100" b="0">
+                          <a:solidFill>
+                            <a:srgbClr val="0B0B0B"/>
+                          </a:solidFill>
+                          <a:latin typeface="Calibri"/>
+                        </a:rPr>
+                        <a:t>20%</a:t>
+                      </a:r>
+                    </a:p>
+                  </a:txBody>
+                  <a:tcPr marT="30000" marB="30000">
+                    <a:solidFill>
+                      <a:srgbClr val="FFFFFF"/>
+                    </a:solidFill>
+                  </a:tcPr>
+                </a:tc>
+                <a:tc>
+                  <a:txBody>
+                    <a:bodyPr/>
+                    <a:lstStyle/>
+                    <a:p>
+                      <a:r>
+                        <a:rPr sz="1100" b="0">
+                          <a:solidFill>
+                            <a:srgbClr val="0B0B0B"/>
+                          </a:solidFill>
+                          <a:latin typeface="Calibri"/>
+                        </a:rPr>
+                        <a:t>2618</a:t>
+                      </a:r>
+                    </a:p>
+                  </a:txBody>
+                  <a:tcPr marT="30000" marB="30000">
+                    <a:solidFill>
+                      <a:srgbClr val="FFFFFF"/>
+                    </a:solidFill>
+                  </a:tcPr>
+                </a:tc>
+                <a:tc>
+                  <a:txBody>
+                    <a:bodyPr/>
+                    <a:lstStyle/>
+                    <a:p>
+                      <a:r>
+                        <a:rPr sz="1100" b="0">
+                          <a:solidFill>
+                            <a:srgbClr val="0B0B0B"/>
+                          </a:solidFill>
+                          <a:latin typeface="Calibri"/>
+                        </a:rPr>
+                        <a:t>$0.124</a:t>
+                      </a:r>
+                    </a:p>
+                  </a:txBody>
+                  <a:tcPr marT="30000" marB="30000">
+                    <a:solidFill>
+                      <a:srgbClr val="FFFFFF"/>
+                    </a:solidFill>
+                  </a:tcPr>
+                </a:tc>
+              </a:tr>
+            </a:tbl>
+          </a:graphicData>
+        </a:graphic>
+      </p:graphicFrame>
+      <p:sp>
+        <p:nvSpPr>
+          <p:cNvPr id="6" name="TextBox 5"/>
+          <p:cNvSpPr txBox="1"/>
+          <p:nvPr/>
+        </p:nvSpPr>
+        <p:spPr>
+          <a:xfrm>
+            <a:off x="7589520" y="4023360"/>
+            <a:ext cx="4297680" cy="4754880"/>
+          </a:xfrm>
+          <a:prstGeom prst="rect">
+            <a:avLst/>
+          </a:prstGeom>
+          <a:noFill/>
+        </p:spPr>
+        <p:txBody>
+          <a:bodyPr wrap="square">
+            <a:spAutoFit/>
+          </a:bodyPr>
+          <a:lstStyle/>
+          <a:p>
+            <a:pPr>
+              <a:spcAft>
+                <a:spcPts val="800"/>
+              </a:spcAft>
+            </a:pPr>
+            <a:r>
+              <a:rPr sz="1300">
+                <a:solidFill>
+                  <a:srgbClr val="0B0B0B"/>
+                </a:solidFill>
+                <a:latin typeface="Calibri"/>
+              </a:rPr>
+              <a:t>• A ≈ C in cost on a smooth ramp; static base B costs 2.2x</a:t>
+            </a:r>
+          </a:p>
+          <a:p>
+            <a:pPr>
+              <a:spcAft>
+                <a:spcPts val="800"/>
+              </a:spcAft>
+            </a:pPr>
+            <a:r>
+              <a:rPr sz="1300">
+                <a:solidFill>
+                  <a:srgbClr val="0B0B0B"/>
+                </a:solidFill>
+                <a:latin typeface="Calibri"/>
+              </a:rPr>
+              <a:t>• Spike (D): 0 failed, but 20% slower than 800 ms</a:t>
+            </a:r>
+          </a:p>
+          <a:p>
+            <a:pPr>
+              <a:spcAft>
+                <a:spcPts val="800"/>
+              </a:spcAft>
+            </a:pPr>
+            <a:r>
+              <a:rPr sz="1300">
+                <a:solidFill>
+                  <a:srgbClr val="0B0B0B"/>
+                </a:solidFill>
+                <a:latin typeface="Calibri"/>
+              </a:rPr>
+              <a:t>• Replay agrees within ~2% for A-C</a:t>
+            </a:r>
+          </a:p>
+          <a:p>
+            <a:pPr>
+              <a:spcAft>
+                <a:spcPts val="800"/>
+              </a:spcAft>
+            </a:pPr>
+            <a:r>
+              <a:rPr sz="1300">
+                <a:solidFill>
+                  <a:srgbClr val="0B0B0B"/>
+                </a:solidFill>
+                <a:latin typeface="Calibri"/>
+              </a:rPr>
+              <a:t>• Weight changes take ~12 s; launch 29-31 s</a:t>
             </a:r>
           </a:p>
         </p:txBody>

</xml_diff>